<commit_message>
docs: Switzerland-wide launch in investor deck + validation protocol; 9%/min-fee unit economics in deck; add TASKS.md with entity-details task
</commit_message>
<xml_diff>
--- a/Shlep_Investor_Deck.pptx
+++ b/Shlep_Investor_Deck.pptx
@@ -4535,7 +4535,7 @@
                 <a:ea typeface="Arial" pitchFamily="34" charset="-122"/>
                 <a:cs typeface="Arial" pitchFamily="34" charset="-120"/>
               </a:rPr>
-              <a:t>Own Zürich, then roll along the rails.</a:t>
+              <a:t>Seed the corridors, then own the rails.</a:t>
             </a:r>
             <a:endParaRPr lang="en-US" sz="3200" dirty="0"/>
           </a:p>
@@ -4650,7 +4650,7 @@
                 <a:ea typeface="Arial" pitchFamily="34" charset="-122"/>
                 <a:cs typeface="Arial" pitchFamily="34" charset="-120"/>
               </a:rPr>
-              <a:t>Zürich beachhead</a:t>
+              <a:t>Corridor beachheads</a:t>
             </a:r>
             <a:endParaRPr lang="en-US" sz="1900" dirty="0"/>
           </a:p>
@@ -4694,7 +4694,7 @@
                 <a:ea typeface="Arial" pitchFamily="34" charset="-122"/>
                 <a:cs typeface="Arial" pitchFamily="34" charset="-120"/>
               </a:rPr>
-              <a:t>Seed dense commuter corridors (Zürich–Winterthur–Zug). Recurring routes create reliable supply.</a:t>
+              <a:t>Seed dense commuter corridors across regions (Zürich–Winterthur, Bern–Thun, Genf–Lausanne). Recurring routes create reliable supply.</a:t>
             </a:r>
             <a:endParaRPr lang="en-US" sz="1300" dirty="0"/>
           </a:p>
@@ -4851,7 +4851,7 @@
                 <a:ea typeface="Arial" pitchFamily="34" charset="-122"/>
                 <a:cs typeface="Arial" pitchFamily="34" charset="-120"/>
               </a:rPr>
-              <a:t>Expand to Basel, Bern, Geneva, Lausanne. Add SME sender accounts and business volume.</a:t>
+              <a:t>Densify into a national network between all major cities. Add SME sender accounts and business volume.</a:t>
             </a:r>
             <a:endParaRPr lang="en-US" sz="1300" dirty="0"/>
           </a:p>
@@ -5273,7 +5273,7 @@
                 <a:ea typeface="Arial" pitchFamily="34" charset="-122"/>
                 <a:cs typeface="Arial" pitchFamily="34" charset="-120"/>
               </a:rPr>
-              <a:t>Raising CHF 750k pre-seed to launch Zürich.</a:t>
+              <a:t>Raising CHF 750k pre-seed to launch Switzerland-wide.</a:t>
             </a:r>
             <a:endParaRPr lang="en-US" sz="3400" dirty="0"/>
           </a:p>
@@ -5317,7 +5317,7 @@
                 <a:ea typeface="Arial" pitchFamily="34" charset="-122"/>
                 <a:cs typeface="Arial" pitchFamily="34" charset="-120"/>
               </a:rPr>
-              <a:t>18 months of runway to prove the Zürich pilot, hit 25k deliveries, and reach the metrics for a seed round.</a:t>
+              <a:t>18 months of runway to prove the launch cohort, hit 25k deliveries, and reach the metrics for a seed round.</a:t>
             </a:r>
             <a:endParaRPr lang="en-US" sz="1500" dirty="0"/>
           </a:p>
@@ -5776,7 +5776,7 @@
                 <a:ea typeface="Arial" pitchFamily="34" charset="-122"/>
                 <a:cs typeface="Arial" pitchFamily="34" charset="-120"/>
               </a:rPr>
-              <a:t>Zürich launch team, support, legal</a:t>
+              <a:t>Launch team, support, legal</a:t>
             </a:r>
             <a:endParaRPr lang="en-US" sz="1200" dirty="0"/>
           </a:p>
@@ -9928,7 +9928,7 @@
                 <a:ea typeface="Arial" pitchFamily="34" charset="-122"/>
                 <a:cs typeface="Arial" pitchFamily="34" charset="-120"/>
               </a:rPr>
-              <a:t>Stripe Connect + TWINT, 90% auto-paid to drivers.</a:t>
+              <a:t>Stripe Connect + TWINT, 91% auto-paid to drivers.</a:t>
             </a:r>
             <a:endParaRPr lang="en-US" sz="1200" dirty="0"/>
           </a:p>
@@ -10611,7 +10611,7 @@
                 <a:ea typeface="Arial" pitchFamily="34" charset="-122"/>
                 <a:cs typeface="Arial" pitchFamily="34" charset="-120"/>
               </a:rPr>
-              <a:t>A 10% take rate on every delivery.</a:t>
+              <a:t>A 9% take rate on every delivery.</a:t>
             </a:r>
             <a:endParaRPr lang="en-US" sz="3200" dirty="0"/>
           </a:p>
@@ -10653,7 +10653,7 @@
                 <a:ea typeface="Arial" pitchFamily="34" charset="-122"/>
                 <a:cs typeface="Arial" pitchFamily="34" charset="-120"/>
               </a:rPr>
-              <a:t>Marketplace economics with near-zero marginal cost. Payment is escrowed on match and split automatically on a code-verified delivery — the platform keeps 10%, the driver keeps 90%.</a:t>
+              <a:t>Marketplace economics with near-zero marginal cost. Payment is escrowed on match and split automatically on a code-verified delivery — the platform keeps 9% (min. CHF 1.50), the driver keeps 91%.</a:t>
             </a:r>
             <a:endParaRPr lang="en-US" sz="1400" dirty="0"/>
           </a:p>
@@ -10866,7 +10866,7 @@
                 <a:ea typeface="Arial" pitchFamily="34" charset="-122"/>
                 <a:cs typeface="Arial" pitchFamily="34" charset="-120"/>
               </a:rPr>
-              <a:t>Driver payout (90%)</a:t>
+              <a:t>Driver payout (91%)</a:t>
             </a:r>
             <a:endParaRPr lang="en-US" sz="1500" dirty="0"/>
           </a:p>
@@ -10905,7 +10905,7 @@
                 <a:ea typeface="Courier New" pitchFamily="34" charset="-122"/>
                 <a:cs typeface="Courier New" pitchFamily="34" charset="-120"/>
               </a:rPr>
-              <a:t>CHF 21.60</a:t>
+              <a:t>CHF 21.84</a:t>
             </a:r>
             <a:endParaRPr lang="en-US" sz="1700" dirty="0"/>
           </a:p>
@@ -10967,7 +10967,7 @@
                 <a:ea typeface="Arial" pitchFamily="34" charset="-122"/>
                 <a:cs typeface="Arial" pitchFamily="34" charset="-120"/>
               </a:rPr>
-              <a:t>Shlep revenue (10%)</a:t>
+              <a:t>Shlep revenue (9%)</a:t>
             </a:r>
             <a:endParaRPr lang="en-US" sz="1500" dirty="0"/>
           </a:p>
@@ -11006,7 +11006,7 @@
                 <a:ea typeface="Courier New" pitchFamily="34" charset="-122"/>
                 <a:cs typeface="Courier New" pitchFamily="34" charset="-120"/>
               </a:rPr>
-              <a:t>CHF 2.40</a:t>
+              <a:t>CHF 2.16</a:t>
             </a:r>
             <a:endParaRPr lang="en-US" sz="1700" dirty="0"/>
           </a:p>
@@ -11143,7 +11143,7 @@
                 <a:ea typeface="Arial" pitchFamily="34" charset="-122"/>
                 <a:cs typeface="Arial" pitchFamily="34" charset="-120"/>
               </a:rPr>
-              <a:t>CHF 2.40</a:t>
+              <a:t>CHF 2.16</a:t>
             </a:r>
             <a:endParaRPr lang="en-US" sz="1200" dirty="0"/>
           </a:p>
@@ -11586,7 +11586,7 @@
                 <a:ea typeface="Arial" pitchFamily="34" charset="-122"/>
                 <a:cs typeface="Arial" pitchFamily="34" charset="-120"/>
               </a:rPr>
-              <a:t>Starting in Zürich, sized for Switzerland.</a:t>
+              <a:t>Switzerland-wide from day one.</a:t>
             </a:r>
             <a:endParaRPr lang="en-US" sz="3200" dirty="0"/>
           </a:p>
@@ -11952,7 +11952,7 @@
                 <a:ea typeface="Arial" pitchFamily="34" charset="-122"/>
                 <a:cs typeface="Arial" pitchFamily="34" charset="-120"/>
               </a:rPr>
-              <a:t>Realistic 3–5 yr capture across Zürich + top Swiss cities.</a:t>
+              <a:t>Realistic 3–5 yr capture across Swiss urban corridors.</a:t>
             </a:r>
             <a:endParaRPr lang="en-US" sz="1300" dirty="0"/>
           </a:p>
@@ -12140,7 +12140,7 @@
                 <a:ea typeface="Arial" pitchFamily="34" charset="-122"/>
                 <a:cs typeface="Arial" pitchFamily="34" charset="-120"/>
               </a:rPr>
-              <a:t>Built and pilot-ready.</a:t>
+              <a:t>Built and launch-ready.</a:t>
             </a:r>
             <a:endParaRPr lang="en-US" sz="3200" dirty="0"/>
           </a:p>
@@ -12728,7 +12728,7 @@
                 <a:ea typeface="Arial" pitchFamily="34" charset="-122"/>
                 <a:cs typeface="Arial" pitchFamily="34" charset="-120"/>
               </a:rPr>
-              <a:t>Launch closed Zürich pilot (commuter corridors)</a:t>
+              <a:t>Launch closed cohort on Swiss commuter corridors</a:t>
             </a:r>
             <a:endParaRPr lang="en-US" sz="1250" dirty="0"/>
           </a:p>

</xml_diff>